<commit_message>
Présentation : URL de démo pointée sur le Space Alh92500
</commit_message>
<xml_diff>
--- a/presentation/Presentation_Paris_Bornes.pptx
+++ b/presentation/Presentation_Paris_Bornes.pptx
@@ -5039,7 +5039,7 @@
                 </a:solidFill>
                 <a:latin typeface="Calibri"/>
               </a:rPr>
-              <a:t>https://huggingface.co/spaces/gregoryjedha/paris-bornes</a:t>
+              <a:t>https://huggingface.co/spaces/Alh92500/paris-bornes</a:t>
             </a:r>
           </a:p>
         </p:txBody>
@@ -6570,7 +6570,7 @@
                 </a:solidFill>
                 <a:latin typeface="Calibri"/>
               </a:rPr>
-              <a:t>https://huggingface.co/spaces/gregoryjedha/paris-bornes</a:t>
+              <a:t>https://huggingface.co/spaces/Alh92500/paris-bornes</a:t>
             </a:r>
           </a:p>
         </p:txBody>

</xml_diff>

<commit_message>
Présentation : démo live + captures app + archi corrigée (données directes)
</commit_message>
<xml_diff>
--- a/presentation/Presentation_Paris_Bornes.pptx
+++ b/presentation/Presentation_Paris_Bornes.pptx
@@ -19,6 +19,12 @@
     <p:sldId id="261" r:id="rId10"/>
     <p:sldId id="262" r:id="rId11"/>
     <p:sldId id="264" r:id="rId12"/>
+    <p:sldId id="268" r:id="rId19"/>
+    <p:sldId id="269" r:id="rId20"/>
+    <p:sldId id="270" r:id="rId21"/>
+    <p:sldId id="271" r:id="rId22"/>
+    <p:sldId id="272" r:id="rId23"/>
+    <p:sldId id="267" r:id="rId18"/>
   </p:sldIdLst>
   <p:sldSz cx="12192000" cy="6858000"/>
   <p:notesSz cx="6858000" cy="9144000"/>
@@ -487,6 +493,131 @@
 </p:notes>
 </file>
 
+<file path=ppt/notesSlides/notesSlide12.xml><?xml version="1.0" encoding="utf-8"?>
+<p:notes xmlns:a="http://schemas.openxmlformats.org/drawingml/2006/main" xmlns:p="http://schemas.openxmlformats.org/presentationml/2006/main" xmlns:r="http://schemas.openxmlformats.org/officeDocument/2006/relationships">
+  <p:cSld>
+    <p:spTree>
+      <p:nvGrpSpPr>
+        <p:cNvPr id="1" name=""/>
+        <p:cNvGrpSpPr/>
+        <p:nvPr/>
+      </p:nvGrpSpPr>
+      <p:grpSpPr>
+        <a:xfrm>
+          <a:off x="0" y="0"/>
+          <a:ext cx="0" cy="0"/>
+          <a:chOff x="0" y="0"/>
+          <a:chExt cx="0" cy="0"/>
+        </a:xfrm>
+      </p:grpSpPr>
+    </p:spTree>
+  </p:cSld>
+  <p:clrMapOvr>
+    <a:masterClrMapping/>
+  </p:clrMapOvr>
+</p:notes>
+</file>
+
+<file path=ppt/notesSlides/notesSlide13.xml><?xml version="1.0" encoding="utf-8"?>
+<p:notes xmlns:a="http://schemas.openxmlformats.org/drawingml/2006/main" xmlns:p="http://schemas.openxmlformats.org/presentationml/2006/main" xmlns:r="http://schemas.openxmlformats.org/officeDocument/2006/relationships">
+  <p:cSld>
+    <p:spTree>
+      <p:nvGrpSpPr>
+        <p:cNvPr id="1" name=""/>
+        <p:cNvGrpSpPr/>
+        <p:nvPr/>
+      </p:nvGrpSpPr>
+      <p:grpSpPr>
+        <a:xfrm>
+          <a:off x="0" y="0"/>
+          <a:ext cx="0" cy="0"/>
+          <a:chOff x="0" y="0"/>
+          <a:chExt cx="0" cy="0"/>
+        </a:xfrm>
+      </p:grpSpPr>
+    </p:spTree>
+  </p:cSld>
+  <p:clrMapOvr>
+    <a:masterClrMapping/>
+  </p:clrMapOvr>
+</p:notes>
+</file>
+
+<file path=ppt/notesSlides/notesSlide14.xml><?xml version="1.0" encoding="utf-8"?>
+<p:notes xmlns:a="http://schemas.openxmlformats.org/drawingml/2006/main" xmlns:p="http://schemas.openxmlformats.org/presentationml/2006/main" xmlns:r="http://schemas.openxmlformats.org/officeDocument/2006/relationships">
+  <p:cSld>
+    <p:spTree>
+      <p:nvGrpSpPr>
+        <p:cNvPr id="1" name=""/>
+        <p:cNvGrpSpPr/>
+        <p:nvPr/>
+      </p:nvGrpSpPr>
+      <p:grpSpPr>
+        <a:xfrm>
+          <a:off x="0" y="0"/>
+          <a:ext cx="0" cy="0"/>
+          <a:chOff x="0" y="0"/>
+          <a:chExt cx="0" cy="0"/>
+        </a:xfrm>
+      </p:grpSpPr>
+    </p:spTree>
+  </p:cSld>
+  <p:clrMapOvr>
+    <a:masterClrMapping/>
+  </p:clrMapOvr>
+</p:notes>
+</file>
+
+<file path=ppt/notesSlides/notesSlide15.xml><?xml version="1.0" encoding="utf-8"?>
+<p:notes xmlns:a="http://schemas.openxmlformats.org/drawingml/2006/main" xmlns:p="http://schemas.openxmlformats.org/presentationml/2006/main" xmlns:r="http://schemas.openxmlformats.org/officeDocument/2006/relationships">
+  <p:cSld>
+    <p:spTree>
+      <p:nvGrpSpPr>
+        <p:cNvPr id="1" name=""/>
+        <p:cNvGrpSpPr/>
+        <p:nvPr/>
+      </p:nvGrpSpPr>
+      <p:grpSpPr>
+        <a:xfrm>
+          <a:off x="0" y="0"/>
+          <a:ext cx="0" cy="0"/>
+          <a:chOff x="0" y="0"/>
+          <a:chExt cx="0" cy="0"/>
+        </a:xfrm>
+      </p:grpSpPr>
+    </p:spTree>
+  </p:cSld>
+  <p:clrMapOvr>
+    <a:masterClrMapping/>
+  </p:clrMapOvr>
+</p:notes>
+</file>
+
+<file path=ppt/notesSlides/notesSlide16.xml><?xml version="1.0" encoding="utf-8"?>
+<p:notes xmlns:a="http://schemas.openxmlformats.org/drawingml/2006/main" xmlns:p="http://schemas.openxmlformats.org/presentationml/2006/main" xmlns:r="http://schemas.openxmlformats.org/officeDocument/2006/relationships">
+  <p:cSld>
+    <p:spTree>
+      <p:nvGrpSpPr>
+        <p:cNvPr id="1" name=""/>
+        <p:cNvGrpSpPr/>
+        <p:nvPr/>
+      </p:nvGrpSpPr>
+      <p:grpSpPr>
+        <a:xfrm>
+          <a:off x="0" y="0"/>
+          <a:ext cx="0" cy="0"/>
+          <a:chOff x="0" y="0"/>
+          <a:chExt cx="0" cy="0"/>
+        </a:xfrm>
+      </p:grpSpPr>
+    </p:spTree>
+  </p:cSld>
+  <p:clrMapOvr>
+    <a:masterClrMapping/>
+  </p:clrMapOvr>
+</p:notes>
+</file>
+
 <file path=ppt/notesSlides/notesSlide2.xml><?xml version="1.0" encoding="utf-8"?>
 <p:notes xmlns:a="http://schemas.openxmlformats.org/drawingml/2006/main" xmlns:r="http://schemas.openxmlformats.org/officeDocument/2006/relationships" xmlns:p="http://schemas.openxmlformats.org/presentationml/2006/main">
   <p:cSld>
@@ -621,17 +752,13 @@
               <a:t>[Axe 4 · Architecture] · 1'00</a:t>
             </a:r>
           </a:p>
-          <a:p>
-            <a:endParaRPr/>
-          </a:p>
-          <a:p>
-            <a:r>
-              <a:t>Stack : Belib', Gireve, OpenChargeMap collectés via Airflow + S3. SQLite, FastAPI, Streamlit, Docker, HF Spaces. Tout est reproductible. Ouvrez le dashboard maintenant — l'URL est ici. Merci.</a:t>
-            </a:r>
-          </a:p>
-          <a:p>
-            <a:endParaRPr/>
-          </a:p>
+          <a:p/>
+          <a:p>
+            <a:r>
+              <a:t>Stack : les données bornes sont récupérées EN DIRECT depuis les données publiques ouvertes (OpenData Ville de Paris — Belib'), nettoyées et normalisées à la volée, puis stockées dans une base SQLite légère. Application Streamlit conteneurisée (Docker) et déployée sur Hugging Face Spaces. Pipeline simple, reproductible, sans dépendance externe. Ouvrez le dashboard maintenant — l'URL est ici.</a:t>
+            </a:r>
+          </a:p>
+          <a:p/>
           <a:p>
             <a:r>
               <a:t>RÈGLE : ne pas lire. Retenir la structure et parler.</a:t>
@@ -5122,6 +5249,571 @@
 </p:sld>
 </file>
 
+<file path=ppt/slides/slide12.xml><?xml version="1.0" encoding="utf-8"?>
+<p:sld xmlns:a="http://schemas.openxmlformats.org/drawingml/2006/main" xmlns:p="http://schemas.openxmlformats.org/presentationml/2006/main" xmlns:r="http://schemas.openxmlformats.org/officeDocument/2006/relationships">
+  <p:cSld>
+    <p:bg>
+      <p:bgPr>
+        <a:solidFill>
+          <a:srgbClr val="0E1B2E"/>
+        </a:solidFill>
+        <a:effectLst/>
+      </p:bgPr>
+    </p:bg>
+    <p:spTree>
+      <p:nvGrpSpPr>
+        <p:cNvPr id="1" name=""/>
+        <p:cNvGrpSpPr/>
+        <p:nvPr/>
+      </p:nvGrpSpPr>
+      <p:grpSpPr/>
+      <p:sp>
+        <p:nvSpPr>
+          <p:cNvPr id="2" name="TextBox 1"/>
+          <p:cNvSpPr txBox="1"/>
+          <p:nvPr/>
+        </p:nvSpPr>
+        <p:spPr>
+          <a:xfrm>
+            <a:off x="457200" y="274320"/>
+            <a:ext cx="11277600" cy="822960"/>
+          </a:xfrm>
+          <a:prstGeom prst="rect">
+            <a:avLst/>
+          </a:prstGeom>
+          <a:noFill/>
+        </p:spPr>
+        <p:txBody>
+          <a:bodyPr wrap="square">
+            <a:spAutoFit/>
+          </a:bodyPr>
+          <a:lstStyle/>
+          <a:p>
+            <a:r>
+              <a:rPr sz="3200" b="1">
+                <a:solidFill>
+                  <a:srgbClr val="FFFFFF"/>
+                </a:solidFill>
+              </a:rPr>
+              <a:t>▶  Démonstration en direct</a:t>
+            </a:r>
+          </a:p>
+        </p:txBody>
+      </p:sp>
+      <p:sp>
+        <p:nvSpPr>
+          <p:cNvPr id="3" name="TextBox 2"/>
+          <p:cNvSpPr txBox="1"/>
+          <p:nvPr/>
+        </p:nvSpPr>
+        <p:spPr>
+          <a:xfrm>
+            <a:off x="640080" y="2103120"/>
+            <a:ext cx="10911840" cy="2286000"/>
+          </a:xfrm>
+          <a:prstGeom prst="rect">
+            <a:avLst/>
+          </a:prstGeom>
+          <a:noFill/>
+        </p:spPr>
+        <p:txBody>
+          <a:bodyPr wrap="square">
+            <a:spAutoFit/>
+          </a:bodyPr>
+          <a:lstStyle/>
+          <a:p>
+            <a:r>
+              <a:rPr sz="2000">
+                <a:solidFill>
+                  <a:srgbClr val="B8C4D4"/>
+                </a:solidFill>
+              </a:rPr>
+              <a:t>Je vous montre l'application en direct :</a:t>
+            </a:r>
+          </a:p>
+          <a:p>
+            <a:r>
+              <a:rPr sz="2200" b="1">
+                <a:solidFill>
+                  <a:srgbClr val="6CB6FF"/>
+                </a:solidFill>
+                <a:hlinkClick r:id="rId2"/>
+              </a:rPr>
+              <a:t>https://huggingface.co/spaces/Alh92500/paris-bornes</a:t>
+            </a:r>
+          </a:p>
+        </p:txBody>
+      </p:sp>
+    </p:spTree>
+  </p:cSld>
+  <p:clrMapOvr>
+    <a:masterClrMapping/>
+  </p:clrMapOvr>
+</p:sld>
+</file>
+
+<file path=ppt/slides/slide13.xml><?xml version="1.0" encoding="utf-8"?>
+<p:sld xmlns:a="http://schemas.openxmlformats.org/drawingml/2006/main" xmlns:p="http://schemas.openxmlformats.org/presentationml/2006/main" xmlns:r="http://schemas.openxmlformats.org/officeDocument/2006/relationships">
+  <p:cSld>
+    <p:bg>
+      <p:bgPr>
+        <a:solidFill>
+          <a:srgbClr val="0E1B2E"/>
+        </a:solidFill>
+        <a:effectLst/>
+      </p:bgPr>
+    </p:bg>
+    <p:spTree>
+      <p:nvGrpSpPr>
+        <p:cNvPr id="1" name=""/>
+        <p:cNvGrpSpPr/>
+        <p:nvPr/>
+      </p:nvGrpSpPr>
+      <p:grpSpPr/>
+      <p:sp>
+        <p:nvSpPr>
+          <p:cNvPr id="2" name="TextBox 1"/>
+          <p:cNvSpPr txBox="1"/>
+          <p:nvPr/>
+        </p:nvSpPr>
+        <p:spPr>
+          <a:xfrm>
+            <a:off x="457200" y="274320"/>
+            <a:ext cx="11277600" cy="822960"/>
+          </a:xfrm>
+          <a:prstGeom prst="rect">
+            <a:avLst/>
+          </a:prstGeom>
+          <a:noFill/>
+        </p:spPr>
+        <p:txBody>
+          <a:bodyPr wrap="square">
+            <a:spAutoFit/>
+          </a:bodyPr>
+          <a:lstStyle/>
+          <a:p>
+            <a:r>
+              <a:rPr sz="2400" b="1">
+                <a:solidFill>
+                  <a:srgbClr val="FFFFFF"/>
+                </a:solidFill>
+              </a:rPr>
+              <a:t>La solution — cartographie des 1900 bornes</a:t>
+            </a:r>
+          </a:p>
+        </p:txBody>
+      </p:sp>
+      <p:pic>
+        <p:nvPicPr>
+          <p:cNvPr id="3" name="Picture 2" descr="app_carte.png"/>
+          <p:cNvPicPr>
+            <a:picLocks noChangeAspect="1"/>
+          </p:cNvPicPr>
+          <p:nvPr/>
+        </p:nvPicPr>
+        <p:blipFill>
+          <a:blip r:embed="rId2"/>
+          <a:stretch>
+            <a:fillRect/>
+          </a:stretch>
+        </p:blipFill>
+        <p:spPr>
+          <a:xfrm>
+            <a:off x="548640" y="1234440"/>
+            <a:ext cx="11094720" cy="6934200"/>
+          </a:xfrm>
+          <a:prstGeom prst="rect">
+            <a:avLst/>
+          </a:prstGeom>
+        </p:spPr>
+      </p:pic>
+    </p:spTree>
+  </p:cSld>
+  <p:clrMapOvr>
+    <a:masterClrMapping/>
+  </p:clrMapOvr>
+</p:sld>
+</file>
+
+<file path=ppt/slides/slide14.xml><?xml version="1.0" encoding="utf-8"?>
+<p:sld xmlns:a="http://schemas.openxmlformats.org/drawingml/2006/main" xmlns:p="http://schemas.openxmlformats.org/presentationml/2006/main" xmlns:r="http://schemas.openxmlformats.org/officeDocument/2006/relationships">
+  <p:cSld>
+    <p:bg>
+      <p:bgPr>
+        <a:solidFill>
+          <a:srgbClr val="0E1B2E"/>
+        </a:solidFill>
+        <a:effectLst/>
+      </p:bgPr>
+    </p:bg>
+    <p:spTree>
+      <p:nvGrpSpPr>
+        <p:cNvPr id="1" name=""/>
+        <p:cNvGrpSpPr/>
+        <p:nvPr/>
+      </p:nvGrpSpPr>
+      <p:grpSpPr/>
+      <p:sp>
+        <p:nvSpPr>
+          <p:cNvPr id="2" name="TextBox 1"/>
+          <p:cNvSpPr txBox="1"/>
+          <p:nvPr/>
+        </p:nvSpPr>
+        <p:spPr>
+          <a:xfrm>
+            <a:off x="457200" y="274320"/>
+            <a:ext cx="11277600" cy="822960"/>
+          </a:xfrm>
+          <a:prstGeom prst="rect">
+            <a:avLst/>
+          </a:prstGeom>
+          <a:noFill/>
+        </p:spPr>
+        <p:txBody>
+          <a:bodyPr wrap="square">
+            <a:spAutoFit/>
+          </a:bodyPr>
+          <a:lstStyle/>
+          <a:p>
+            <a:r>
+              <a:rPr sz="2400" b="1">
+                <a:solidFill>
+                  <a:srgbClr val="FFFFFF"/>
+                </a:solidFill>
+              </a:rPr>
+              <a:t>Pression — où ça coince aujourd'hui</a:t>
+            </a:r>
+          </a:p>
+        </p:txBody>
+      </p:sp>
+      <p:pic>
+        <p:nvPicPr>
+          <p:cNvPr id="3" name="Picture 2" descr="app_pression.png"/>
+          <p:cNvPicPr>
+            <a:picLocks noChangeAspect="1"/>
+          </p:cNvPicPr>
+          <p:nvPr/>
+        </p:nvPicPr>
+        <p:blipFill>
+          <a:blip r:embed="rId2"/>
+          <a:stretch>
+            <a:fillRect/>
+          </a:stretch>
+        </p:blipFill>
+        <p:spPr>
+          <a:xfrm>
+            <a:off x="548640" y="1234440"/>
+            <a:ext cx="11094720" cy="6934200"/>
+          </a:xfrm>
+          <a:prstGeom prst="rect">
+            <a:avLst/>
+          </a:prstGeom>
+        </p:spPr>
+      </p:pic>
+    </p:spTree>
+  </p:cSld>
+  <p:clrMapOvr>
+    <a:masterClrMapping/>
+  </p:clrMapOvr>
+</p:sld>
+</file>
+
+<file path=ppt/slides/slide15.xml><?xml version="1.0" encoding="utf-8"?>
+<p:sld xmlns:a="http://schemas.openxmlformats.org/drawingml/2006/main" xmlns:p="http://schemas.openxmlformats.org/presentationml/2006/main" xmlns:r="http://schemas.openxmlformats.org/officeDocument/2006/relationships">
+  <p:cSld>
+    <p:bg>
+      <p:bgPr>
+        <a:solidFill>
+          <a:srgbClr val="0E1B2E"/>
+        </a:solidFill>
+        <a:effectLst/>
+      </p:bgPr>
+    </p:bg>
+    <p:spTree>
+      <p:nvGrpSpPr>
+        <p:cNvPr id="1" name=""/>
+        <p:cNvGrpSpPr/>
+        <p:nvPr/>
+      </p:nvGrpSpPr>
+      <p:grpSpPr/>
+      <p:sp>
+        <p:nvSpPr>
+          <p:cNvPr id="2" name="TextBox 1"/>
+          <p:cNvSpPr txBox="1"/>
+          <p:nvPr/>
+        </p:nvSpPr>
+        <p:spPr>
+          <a:xfrm>
+            <a:off x="457200" y="274320"/>
+            <a:ext cx="11277600" cy="822960"/>
+          </a:xfrm>
+          <a:prstGeom prst="rect">
+            <a:avLst/>
+          </a:prstGeom>
+          <a:noFill/>
+        </p:spPr>
+        <p:txBody>
+          <a:bodyPr wrap="square">
+            <a:spAutoFit/>
+          </a:bodyPr>
+          <a:lstStyle/>
+          <a:p>
+            <a:r>
+              <a:rPr sz="2400" b="1">
+                <a:solidFill>
+                  <a:srgbClr val="FFFFFF"/>
+                </a:solidFill>
+              </a:rPr>
+              <a:t>Projection — combien de bornes à 3 ans</a:t>
+            </a:r>
+          </a:p>
+        </p:txBody>
+      </p:sp>
+      <p:pic>
+        <p:nvPicPr>
+          <p:cNvPr id="3" name="Picture 2" descr="app_projection.png"/>
+          <p:cNvPicPr>
+            <a:picLocks noChangeAspect="1"/>
+          </p:cNvPicPr>
+          <p:nvPr/>
+        </p:nvPicPr>
+        <p:blipFill>
+          <a:blip r:embed="rId2"/>
+          <a:stretch>
+            <a:fillRect/>
+          </a:stretch>
+        </p:blipFill>
+        <p:spPr>
+          <a:xfrm>
+            <a:off x="548640" y="1234440"/>
+            <a:ext cx="11094720" cy="6934200"/>
+          </a:xfrm>
+          <a:prstGeom prst="rect">
+            <a:avLst/>
+          </a:prstGeom>
+        </p:spPr>
+      </p:pic>
+    </p:spTree>
+  </p:cSld>
+  <p:clrMapOvr>
+    <a:masterClrMapping/>
+  </p:clrMapOvr>
+</p:sld>
+</file>
+
+<file path=ppt/slides/slide16.xml><?xml version="1.0" encoding="utf-8"?>
+<p:sld xmlns:a="http://schemas.openxmlformats.org/drawingml/2006/main" xmlns:p="http://schemas.openxmlformats.org/presentationml/2006/main" xmlns:r="http://schemas.openxmlformats.org/officeDocument/2006/relationships">
+  <p:cSld>
+    <p:bg>
+      <p:bgPr>
+        <a:solidFill>
+          <a:srgbClr val="0E1B2E"/>
+        </a:solidFill>
+        <a:effectLst/>
+      </p:bgPr>
+    </p:bg>
+    <p:spTree>
+      <p:nvGrpSpPr>
+        <p:cNvPr id="1" name=""/>
+        <p:cNvGrpSpPr/>
+        <p:nvPr/>
+      </p:nvGrpSpPr>
+      <p:grpSpPr/>
+      <p:sp>
+        <p:nvSpPr>
+          <p:cNvPr id="2" name="TextBox 1"/>
+          <p:cNvSpPr txBox="1"/>
+          <p:nvPr/>
+        </p:nvSpPr>
+        <p:spPr>
+          <a:xfrm>
+            <a:off x="457200" y="274320"/>
+            <a:ext cx="11277600" cy="822960"/>
+          </a:xfrm>
+          <a:prstGeom prst="rect">
+            <a:avLst/>
+          </a:prstGeom>
+          <a:noFill/>
+        </p:spPr>
+        <p:txBody>
+          <a:bodyPr wrap="square">
+            <a:spAutoFit/>
+          </a:bodyPr>
+          <a:lstStyle/>
+          <a:p>
+            <a:r>
+              <a:rPr sz="2400" b="1">
+                <a:solidFill>
+                  <a:srgbClr val="FFFFFF"/>
+                </a:solidFill>
+              </a:rPr>
+              <a:t>Soutenabilité — le réseau tient-il ?</a:t>
+            </a:r>
+          </a:p>
+        </p:txBody>
+      </p:sp>
+      <p:pic>
+        <p:nvPicPr>
+          <p:cNvPr id="3" name="Picture 2" descr="app_soutenabilite.png"/>
+          <p:cNvPicPr>
+            <a:picLocks noChangeAspect="1"/>
+          </p:cNvPicPr>
+          <p:nvPr/>
+        </p:nvPicPr>
+        <p:blipFill>
+          <a:blip r:embed="rId2"/>
+          <a:stretch>
+            <a:fillRect/>
+          </a:stretch>
+        </p:blipFill>
+        <p:spPr>
+          <a:xfrm>
+            <a:off x="548640" y="1234440"/>
+            <a:ext cx="11094720" cy="6934200"/>
+          </a:xfrm>
+          <a:prstGeom prst="rect">
+            <a:avLst/>
+          </a:prstGeom>
+        </p:spPr>
+      </p:pic>
+    </p:spTree>
+  </p:cSld>
+  <p:clrMapOvr>
+    <a:masterClrMapping/>
+  </p:clrMapOvr>
+</p:sld>
+</file>
+
+<file path=ppt/slides/slide17.xml><?xml version="1.0" encoding="utf-8"?>
+<p:sld xmlns:a="http://schemas.openxmlformats.org/drawingml/2006/main" xmlns:p="http://schemas.openxmlformats.org/presentationml/2006/main" xmlns:r="http://schemas.openxmlformats.org/officeDocument/2006/relationships">
+  <p:cSld>
+    <p:bg>
+      <p:bgPr>
+        <a:solidFill>
+          <a:srgbClr val="0E1B2E"/>
+        </a:solidFill>
+        <a:effectLst/>
+      </p:bgPr>
+    </p:bg>
+    <p:spTree>
+      <p:nvGrpSpPr>
+        <p:cNvPr id="1" name=""/>
+        <p:cNvGrpSpPr/>
+        <p:nvPr/>
+      </p:nvGrpSpPr>
+      <p:grpSpPr/>
+      <p:sp>
+        <p:nvSpPr>
+          <p:cNvPr id="2" name="TextBox 1"/>
+          <p:cNvSpPr txBox="1"/>
+          <p:nvPr/>
+        </p:nvSpPr>
+        <p:spPr>
+          <a:xfrm>
+            <a:off x="548640" y="548640"/>
+            <a:ext cx="11094720" cy="914400"/>
+          </a:xfrm>
+          <a:prstGeom prst="rect">
+            <a:avLst/>
+          </a:prstGeom>
+          <a:noFill/>
+        </p:spPr>
+        <p:txBody>
+          <a:bodyPr wrap="none">
+            <a:spAutoFit/>
+          </a:bodyPr>
+          <a:lstStyle/>
+          <a:p>
+            <a:r>
+              <a:rPr sz="3400" b="1">
+                <a:solidFill>
+                  <a:srgbClr val="FFFFFF"/>
+                </a:solidFill>
+              </a:rPr>
+              <a:t>🔗 Liens du projet</a:t>
+            </a:r>
+          </a:p>
+        </p:txBody>
+      </p:sp>
+      <p:sp>
+        <p:nvSpPr>
+          <p:cNvPr id="3" name="TextBox 2"/>
+          <p:cNvSpPr txBox="1"/>
+          <p:nvPr/>
+        </p:nvSpPr>
+        <p:spPr>
+          <a:xfrm>
+            <a:off x="548640" y="1828800"/>
+            <a:ext cx="11094720" cy="3200400"/>
+          </a:xfrm>
+          <a:prstGeom prst="rect">
+            <a:avLst/>
+          </a:prstGeom>
+          <a:noFill/>
+        </p:spPr>
+        <p:txBody>
+          <a:bodyPr wrap="square">
+            <a:spAutoFit/>
+          </a:bodyPr>
+          <a:lstStyle/>
+          <a:p>
+            <a:pPr>
+              <a:spcAft>
+                <a:spcPts val="1000"/>
+              </a:spcAft>
+            </a:pPr>
+            <a:r>
+              <a:rPr sz="1800">
+                <a:solidFill>
+                  <a:srgbClr val="B8C4D4"/>
+                </a:solidFill>
+              </a:rPr>
+              <a:t>Code (GitHub) : </a:t>
+            </a:r>
+            <a:r>
+              <a:rPr sz="1800">
+                <a:solidFill>
+                  <a:srgbClr val="6CB6FF"/>
+                </a:solidFill>
+                <a:hlinkClick r:id="rId2"/>
+              </a:rPr>
+              <a:t>https://github.com/aymericlahonde-dotcom/cdsd-b6-paris-bornes</a:t>
+            </a:r>
+          </a:p>
+          <a:p>
+            <a:pPr>
+              <a:spcAft>
+                <a:spcPts val="1000"/>
+              </a:spcAft>
+            </a:pPr>
+            <a:r>
+              <a:rPr sz="1800">
+                <a:solidFill>
+                  <a:srgbClr val="B8C4D4"/>
+                </a:solidFill>
+              </a:rPr>
+              <a:t>Application (HF) : </a:t>
+            </a:r>
+            <a:r>
+              <a:rPr sz="1800">
+                <a:solidFill>
+                  <a:srgbClr val="6CB6FF"/>
+                </a:solidFill>
+                <a:hlinkClick r:id="rId3"/>
+              </a:rPr>
+              <a:t>https://huggingface.co/spaces/Alh92500/paris-bornes</a:t>
+            </a:r>
+          </a:p>
+        </p:txBody>
+      </p:sp>
+    </p:spTree>
+  </p:cSld>
+  <p:clrMapOvr>
+    <a:masterClrMapping/>
+  </p:clrMapOvr>
+</p:sld>
+</file>
+
 <file path=ppt/slides/slide2.xml><?xml version="1.0" encoding="utf-8"?>
 <p:sld xmlns:a="http://schemas.openxmlformats.org/drawingml/2006/main" xmlns:r="http://schemas.openxmlformats.org/officeDocument/2006/relationships" xmlns:p="http://schemas.openxmlformats.org/presentationml/2006/main">
   <p:cSld>
@@ -6219,7 +6911,7 @@
                 </a:solidFill>
                 <a:latin typeface="Calibri"/>
               </a:rPr>
-              <a:t>Belib' · Gireve · OpenChargeMap · SQLite · FastAPI · Streamlit · Docker · HF Spaces</a:t>
+              <a:t>Belib' (OpenData Ville de Paris)  →  récupération directe + nettoyage  →  SQLite  →  Streamlit  →  Docker  →  HF Spaces</a:t>
             </a:r>
           </a:p>
         </p:txBody>

</xml_diff>

<commit_message>
Monitoring intégré + dossier réaligné (RGPD, budget, cible vs MVP) + Q&A jury
- App : nouvel onglet Suivi & monitoring (qualité données, résultats modèle, usage anonyme)
- Dossier docx : sections RGPD (ch.11), Budget (ch.12), mise au point architecture cible vs MVP livré (ch.13) ; MLflow reclassé en cible, monitoring réel décrit
- Présentation : slides Conformité RGPD et Budget avant Merci
- README : RGPD + monitoring ; PREPARE_JURY.md (Q&A soutenance)
</commit_message>
<xml_diff>
--- a/presentation/Presentation_Paris_Bornes.pptx
+++ b/presentation/Presentation_Paris_Bornes.pptx
@@ -18,6 +18,8 @@
     <p:sldId id="260" r:id="rId9"/>
     <p:sldId id="261" r:id="rId10"/>
     <p:sldId id="262" r:id="rId11"/>
+    <p:sldId id="273" r:id="rId24"/>
+    <p:sldId id="274" r:id="rId25"/>
     <p:sldId id="264" r:id="rId12"/>
     <p:sldId id="268" r:id="rId19"/>
     <p:sldId id="269" r:id="rId20"/>
@@ -5802,6 +5804,702 @@
                 <a:hlinkClick r:id="rId3"/>
               </a:rPr>
               <a:t>https://huggingface.co/spaces/Alh92500/paris-bornes</a:t>
+            </a:r>
+          </a:p>
+        </p:txBody>
+      </p:sp>
+    </p:spTree>
+  </p:cSld>
+  <p:clrMapOvr>
+    <a:masterClrMapping/>
+  </p:clrMapOvr>
+</p:sld>
+</file>
+
+<file path=ppt/slides/slide18.xml><?xml version="1.0" encoding="utf-8"?>
+<p:sld xmlns:a="http://schemas.openxmlformats.org/drawingml/2006/main" xmlns:p="http://schemas.openxmlformats.org/presentationml/2006/main" xmlns:r="http://schemas.openxmlformats.org/officeDocument/2006/relationships">
+  <p:cSld>
+    <p:spTree>
+      <p:nvGrpSpPr>
+        <p:cNvPr id="1" name=""/>
+        <p:cNvGrpSpPr/>
+        <p:nvPr/>
+      </p:nvGrpSpPr>
+      <p:grpSpPr/>
+      <p:sp>
+        <p:nvSpPr>
+          <p:cNvPr id="2" name="Rectangle 1"/>
+          <p:cNvSpPr/>
+          <p:nvPr/>
+        </p:nvSpPr>
+        <p:spPr>
+          <a:xfrm>
+            <a:off x="0" y="0"/>
+            <a:ext cx="12192000" cy="6858000"/>
+          </a:xfrm>
+          <a:prstGeom prst="rect">
+            <a:avLst/>
+          </a:prstGeom>
+          <a:solidFill>
+            <a:srgbClr val="0E2A20"/>
+          </a:solidFill>
+          <a:ln>
+            <a:noFill/>
+          </a:ln>
+          <a:effectLst/>
+        </p:spPr>
+        <p:style>
+          <a:lnRef idx="1">
+            <a:schemeClr val="accent1"/>
+          </a:lnRef>
+          <a:fillRef idx="3">
+            <a:schemeClr val="accent1"/>
+          </a:fillRef>
+          <a:effectRef idx="2">
+            <a:schemeClr val="accent1"/>
+          </a:effectRef>
+          <a:fontRef idx="minor">
+            <a:schemeClr val="lt1"/>
+          </a:fontRef>
+        </p:style>
+        <p:txBody>
+          <a:bodyPr rtlCol="0" anchor="ctr"/>
+          <a:lstStyle/>
+          <a:p>
+            <a:pPr algn="ctr"/>
+          </a:p>
+        </p:txBody>
+      </p:sp>
+      <p:sp>
+        <p:nvSpPr>
+          <p:cNvPr id="3" name="Rectangle 2"/>
+          <p:cNvSpPr/>
+          <p:nvPr/>
+        </p:nvSpPr>
+        <p:spPr>
+          <a:xfrm>
+            <a:off x="0" y="0"/>
+            <a:ext cx="164592" cy="6858000"/>
+          </a:xfrm>
+          <a:prstGeom prst="rect">
+            <a:avLst/>
+          </a:prstGeom>
+          <a:solidFill>
+            <a:srgbClr val="2EF598"/>
+          </a:solidFill>
+          <a:ln>
+            <a:noFill/>
+          </a:ln>
+          <a:effectLst/>
+        </p:spPr>
+        <p:style>
+          <a:lnRef idx="1">
+            <a:schemeClr val="accent1"/>
+          </a:lnRef>
+          <a:fillRef idx="3">
+            <a:schemeClr val="accent1"/>
+          </a:fillRef>
+          <a:effectRef idx="2">
+            <a:schemeClr val="accent1"/>
+          </a:effectRef>
+          <a:fontRef idx="minor">
+            <a:schemeClr val="lt1"/>
+          </a:fontRef>
+        </p:style>
+        <p:txBody>
+          <a:bodyPr rtlCol="0" anchor="ctr"/>
+          <a:lstStyle/>
+          <a:p>
+            <a:pPr algn="ctr"/>
+          </a:p>
+        </p:txBody>
+      </p:sp>
+      <p:sp>
+        <p:nvSpPr>
+          <p:cNvPr id="4" name="TextBox 3"/>
+          <p:cNvSpPr txBox="1"/>
+          <p:nvPr/>
+        </p:nvSpPr>
+        <p:spPr>
+          <a:xfrm>
+            <a:off x="731520" y="502920"/>
+            <a:ext cx="10515600" cy="457200"/>
+          </a:xfrm>
+          <a:prstGeom prst="rect">
+            <a:avLst/>
+          </a:prstGeom>
+          <a:noFill/>
+        </p:spPr>
+        <p:txBody>
+          <a:bodyPr wrap="square">
+            <a:spAutoFit/>
+          </a:bodyPr>
+          <a:lstStyle/>
+          <a:p>
+            <a:r>
+              <a:rPr sz="1400" b="1">
+                <a:solidFill>
+                  <a:srgbClr val="2EF598"/>
+                </a:solidFill>
+              </a:rPr>
+              <a:t>CONFORMITÉ · RGPD</a:t>
+            </a:r>
+          </a:p>
+        </p:txBody>
+      </p:sp>
+      <p:sp>
+        <p:nvSpPr>
+          <p:cNvPr id="5" name="TextBox 4"/>
+          <p:cNvSpPr txBox="1"/>
+          <p:nvPr/>
+        </p:nvSpPr>
+        <p:spPr>
+          <a:xfrm>
+            <a:off x="731520" y="960120"/>
+            <a:ext cx="10515600" cy="1097280"/>
+          </a:xfrm>
+          <a:prstGeom prst="rect">
+            <a:avLst/>
+          </a:prstGeom>
+          <a:noFill/>
+        </p:spPr>
+        <p:txBody>
+          <a:bodyPr wrap="square">
+            <a:spAutoFit/>
+          </a:bodyPr>
+          <a:lstStyle/>
+          <a:p>
+            <a:r>
+              <a:rPr sz="3400" b="1">
+                <a:solidFill>
+                  <a:srgbClr val="FFFFFF"/>
+                </a:solidFill>
+              </a:rPr>
+              <a:t>Conformité RGPD — aucune donnée personnelle</a:t>
+            </a:r>
+          </a:p>
+        </p:txBody>
+      </p:sp>
+      <p:sp>
+        <p:nvSpPr>
+          <p:cNvPr id="6" name="TextBox 5"/>
+          <p:cNvSpPr txBox="1"/>
+          <p:nvPr/>
+        </p:nvSpPr>
+        <p:spPr>
+          <a:xfrm>
+            <a:off x="777240" y="2286000"/>
+            <a:ext cx="10607040" cy="3840480"/>
+          </a:xfrm>
+          <a:prstGeom prst="rect">
+            <a:avLst/>
+          </a:prstGeom>
+          <a:noFill/>
+        </p:spPr>
+        <p:txBody>
+          <a:bodyPr wrap="square">
+            <a:spAutoFit/>
+          </a:bodyPr>
+          <a:lstStyle/>
+          <a:p>
+            <a:pPr>
+              <a:spcAft>
+                <a:spcPts val="1000"/>
+              </a:spcAft>
+            </a:pPr>
+            <a:r>
+              <a:rPr sz="2000" b="1">
+                <a:solidFill>
+                  <a:srgbClr val="FFFFFF"/>
+                </a:solidFill>
+              </a:rPr>
+              <a:t>▸  100 % données ouvertes et agrégées</a:t>
+            </a:r>
+          </a:p>
+          <a:p>
+            <a:pPr>
+              <a:spcAft>
+                <a:spcPts val="1000"/>
+              </a:spcAft>
+            </a:pPr>
+            <a:r>
+              <a:rPr sz="1500">
+                <a:solidFill>
+                  <a:srgbClr val="C8DEED"/>
+                </a:solidFill>
+              </a:rPr>
+              <a:t>      Belib' (OpenData Paris), parc VE (SDES/data.gouv), Enedis, INSEE — maille arrondissement, jamais l'individu</a:t>
+            </a:r>
+          </a:p>
+          <a:p>
+            <a:pPr>
+              <a:spcAft>
+                <a:spcPts val="1000"/>
+              </a:spcAft>
+            </a:pPr>
+            <a:r>
+              <a:rPr sz="2000" b="1">
+                <a:solidFill>
+                  <a:srgbClr val="FFFFFF"/>
+                </a:solidFill>
+              </a:rPr>
+              <a:t>▸  Aucune donnée personnelle (PII)</a:t>
+            </a:r>
+          </a:p>
+          <a:p>
+            <a:pPr>
+              <a:spcAft>
+                <a:spcPts val="1000"/>
+              </a:spcAft>
+            </a:pPr>
+            <a:r>
+              <a:rPr sz="1500">
+                <a:solidFill>
+                  <a:srgbClr val="C8DEED"/>
+                </a:solidFill>
+              </a:rPr>
+              <a:t>      Pas de nom, pas d'immatriculation, pas d'adresse d'usager — hors champ RGPD art. 4</a:t>
+            </a:r>
+          </a:p>
+          <a:p>
+            <a:pPr>
+              <a:spcAft>
+                <a:spcPts val="1000"/>
+              </a:spcAft>
+            </a:pPr>
+            <a:r>
+              <a:rPr sz="2000" b="1">
+                <a:solidFill>
+                  <a:srgbClr val="FFFFFF"/>
+                </a:solidFill>
+              </a:rPr>
+              <a:t>▸  Aucun traçage utilisateur</a:t>
+            </a:r>
+          </a:p>
+          <a:p>
+            <a:pPr>
+              <a:spcAft>
+                <a:spcPts val="1000"/>
+              </a:spcAft>
+            </a:pPr>
+            <a:r>
+              <a:rPr sz="1500">
+                <a:solidFill>
+                  <a:srgbClr val="C8DEED"/>
+                </a:solidFill>
+              </a:rPr>
+              <a:t>      Pas de cookie, pas d'authentification, pas d'IP — suivi d'usage anonyme (horodatage serveur)</a:t>
+            </a:r>
+          </a:p>
+          <a:p>
+            <a:pPr>
+              <a:spcAft>
+                <a:spcPts val="1000"/>
+              </a:spcAft>
+            </a:pPr>
+            <a:r>
+              <a:rPr sz="2000" b="1">
+                <a:solidFill>
+                  <a:srgbClr val="FFFFFF"/>
+                </a:solidFill>
+              </a:rPr>
+              <a:t>▸  Licences ouvertes + principes CNIL</a:t>
+            </a:r>
+          </a:p>
+          <a:p>
+            <a:pPr>
+              <a:spcAft>
+                <a:spcPts val="1000"/>
+              </a:spcAft>
+            </a:pPr>
+            <a:r>
+              <a:rPr sz="1500">
+                <a:solidFill>
+                  <a:srgbClr val="C8DEED"/>
+                </a:solidFill>
+              </a:rPr>
+              <a:t>      Licence Ouverte Etalab / ODbL · minimisation, transparence, aucun secret dans le dépôt Git</a:t>
+            </a:r>
+          </a:p>
+        </p:txBody>
+      </p:sp>
+      <p:sp>
+        <p:nvSpPr>
+          <p:cNvPr id="7" name="TextBox 6"/>
+          <p:cNvSpPr txBox="1"/>
+          <p:nvPr/>
+        </p:nvSpPr>
+        <p:spPr>
+          <a:xfrm>
+            <a:off x="731520" y="6400800"/>
+            <a:ext cx="10607040" cy="365760"/>
+          </a:xfrm>
+          <a:prstGeom prst="rect">
+            <a:avLst/>
+          </a:prstGeom>
+          <a:noFill/>
+        </p:spPr>
+        <p:txBody>
+          <a:bodyPr wrap="square">
+            <a:spAutoFit/>
+          </a:bodyPr>
+          <a:lstStyle/>
+          <a:p>
+            <a:r>
+              <a:rPr sz="1000">
+                <a:solidFill>
+                  <a:srgbClr val="C8DEED"/>
+                </a:solidFill>
+              </a:rPr>
+              <a:t>Bornes de recharge VE — Paris · Projet Final Jedha   ·   RGPD</a:t>
+            </a:r>
+          </a:p>
+        </p:txBody>
+      </p:sp>
+    </p:spTree>
+  </p:cSld>
+  <p:clrMapOvr>
+    <a:masterClrMapping/>
+  </p:clrMapOvr>
+</p:sld>
+</file>
+
+<file path=ppt/slides/slide19.xml><?xml version="1.0" encoding="utf-8"?>
+<p:sld xmlns:a="http://schemas.openxmlformats.org/drawingml/2006/main" xmlns:p="http://schemas.openxmlformats.org/presentationml/2006/main" xmlns:r="http://schemas.openxmlformats.org/officeDocument/2006/relationships">
+  <p:cSld>
+    <p:spTree>
+      <p:nvGrpSpPr>
+        <p:cNvPr id="1" name=""/>
+        <p:cNvGrpSpPr/>
+        <p:nvPr/>
+      </p:nvGrpSpPr>
+      <p:grpSpPr/>
+      <p:sp>
+        <p:nvSpPr>
+          <p:cNvPr id="2" name="Rectangle 1"/>
+          <p:cNvSpPr/>
+          <p:nvPr/>
+        </p:nvSpPr>
+        <p:spPr>
+          <a:xfrm>
+            <a:off x="0" y="0"/>
+            <a:ext cx="12192000" cy="6858000"/>
+          </a:xfrm>
+          <a:prstGeom prst="rect">
+            <a:avLst/>
+          </a:prstGeom>
+          <a:solidFill>
+            <a:srgbClr val="0E2A20"/>
+          </a:solidFill>
+          <a:ln>
+            <a:noFill/>
+          </a:ln>
+          <a:effectLst/>
+        </p:spPr>
+        <p:style>
+          <a:lnRef idx="1">
+            <a:schemeClr val="accent1"/>
+          </a:lnRef>
+          <a:fillRef idx="3">
+            <a:schemeClr val="accent1"/>
+          </a:fillRef>
+          <a:effectRef idx="2">
+            <a:schemeClr val="accent1"/>
+          </a:effectRef>
+          <a:fontRef idx="minor">
+            <a:schemeClr val="lt1"/>
+          </a:fontRef>
+        </p:style>
+        <p:txBody>
+          <a:bodyPr rtlCol="0" anchor="ctr"/>
+          <a:lstStyle/>
+          <a:p>
+            <a:pPr algn="ctr"/>
+          </a:p>
+        </p:txBody>
+      </p:sp>
+      <p:sp>
+        <p:nvSpPr>
+          <p:cNvPr id="3" name="Rectangle 2"/>
+          <p:cNvSpPr/>
+          <p:nvPr/>
+        </p:nvSpPr>
+        <p:spPr>
+          <a:xfrm>
+            <a:off x="0" y="0"/>
+            <a:ext cx="164592" cy="6858000"/>
+          </a:xfrm>
+          <a:prstGeom prst="rect">
+            <a:avLst/>
+          </a:prstGeom>
+          <a:solidFill>
+            <a:srgbClr val="2EF598"/>
+          </a:solidFill>
+          <a:ln>
+            <a:noFill/>
+          </a:ln>
+          <a:effectLst/>
+        </p:spPr>
+        <p:style>
+          <a:lnRef idx="1">
+            <a:schemeClr val="accent1"/>
+          </a:lnRef>
+          <a:fillRef idx="3">
+            <a:schemeClr val="accent1"/>
+          </a:fillRef>
+          <a:effectRef idx="2">
+            <a:schemeClr val="accent1"/>
+          </a:effectRef>
+          <a:fontRef idx="minor">
+            <a:schemeClr val="lt1"/>
+          </a:fontRef>
+        </p:style>
+        <p:txBody>
+          <a:bodyPr rtlCol="0" anchor="ctr"/>
+          <a:lstStyle/>
+          <a:p>
+            <a:pPr algn="ctr"/>
+          </a:p>
+        </p:txBody>
+      </p:sp>
+      <p:sp>
+        <p:nvSpPr>
+          <p:cNvPr id="4" name="TextBox 3"/>
+          <p:cNvSpPr txBox="1"/>
+          <p:nvPr/>
+        </p:nvSpPr>
+        <p:spPr>
+          <a:xfrm>
+            <a:off x="731520" y="502920"/>
+            <a:ext cx="10515600" cy="457200"/>
+          </a:xfrm>
+          <a:prstGeom prst="rect">
+            <a:avLst/>
+          </a:prstGeom>
+          <a:noFill/>
+        </p:spPr>
+        <p:txBody>
+          <a:bodyPr wrap="square">
+            <a:spAutoFit/>
+          </a:bodyPr>
+          <a:lstStyle/>
+          <a:p>
+            <a:r>
+              <a:rPr sz="1400" b="1">
+                <a:solidFill>
+                  <a:srgbClr val="2EF598"/>
+                </a:solidFill>
+              </a:rPr>
+              <a:t>GESTION DE PROJET · BUDGET</a:t>
+            </a:r>
+          </a:p>
+        </p:txBody>
+      </p:sp>
+      <p:sp>
+        <p:nvSpPr>
+          <p:cNvPr id="5" name="TextBox 4"/>
+          <p:cNvSpPr txBox="1"/>
+          <p:nvPr/>
+        </p:nvSpPr>
+        <p:spPr>
+          <a:xfrm>
+            <a:off x="731520" y="960120"/>
+            <a:ext cx="10515600" cy="1097280"/>
+          </a:xfrm>
+          <a:prstGeom prst="rect">
+            <a:avLst/>
+          </a:prstGeom>
+          <a:noFill/>
+        </p:spPr>
+        <p:txBody>
+          <a:bodyPr wrap="square">
+            <a:spAutoFit/>
+          </a:bodyPr>
+          <a:lstStyle/>
+          <a:p>
+            <a:r>
+              <a:rPr sz="3400" b="1">
+                <a:solidFill>
+                  <a:srgbClr val="FFFFFF"/>
+                </a:solidFill>
+              </a:rPr>
+              <a:t>Budget &amp; coûts — ~0 € pour piloter des dizaines de M€</a:t>
+            </a:r>
+          </a:p>
+        </p:txBody>
+      </p:sp>
+      <p:sp>
+        <p:nvSpPr>
+          <p:cNvPr id="6" name="TextBox 5"/>
+          <p:cNvSpPr txBox="1"/>
+          <p:nvPr/>
+        </p:nvSpPr>
+        <p:spPr>
+          <a:xfrm>
+            <a:off x="777240" y="2286000"/>
+            <a:ext cx="10607040" cy="3840480"/>
+          </a:xfrm>
+          <a:prstGeom prst="rect">
+            <a:avLst/>
+          </a:prstGeom>
+          <a:noFill/>
+        </p:spPr>
+        <p:txBody>
+          <a:bodyPr wrap="square">
+            <a:spAutoFit/>
+          </a:bodyPr>
+          <a:lstStyle/>
+          <a:p>
+            <a:pPr>
+              <a:spcAft>
+                <a:spcPts val="1000"/>
+              </a:spcAft>
+            </a:pPr>
+            <a:r>
+              <a:rPr sz="2000" b="1">
+                <a:solidFill>
+                  <a:srgbClr val="FFFFFF"/>
+                </a:solidFill>
+              </a:rPr>
+              <a:t>▸  Solution data (MVP livré) : ~0 €/mois</a:t>
+            </a:r>
+          </a:p>
+          <a:p>
+            <a:pPr>
+              <a:spcAft>
+                <a:spcPts val="1000"/>
+              </a:spcAft>
+            </a:pPr>
+            <a:r>
+              <a:rPr sz="1500">
+                <a:solidFill>
+                  <a:srgbClr val="C8DEED"/>
+                </a:solidFill>
+              </a:rPr>
+              <a:t>      Hugging Face Spaces gratuit · OpenData gratuit · GitHub public — aucun service payant</a:t>
+            </a:r>
+          </a:p>
+          <a:p>
+            <a:pPr>
+              <a:spcAft>
+                <a:spcPts val="1000"/>
+              </a:spcAft>
+            </a:pPr>
+            <a:r>
+              <a:rPr sz="2000" b="1">
+                <a:solidFill>
+                  <a:srgbClr val="FFFFFF"/>
+                </a:solidFill>
+              </a:rPr>
+              <a:t>▸  Coût humain : équipe de 4 · 4-5 jours</a:t>
+            </a:r>
+          </a:p>
+          <a:p>
+            <a:pPr>
+              <a:spcAft>
+                <a:spcPts val="1000"/>
+              </a:spcAft>
+            </a:pPr>
+            <a:r>
+              <a:rPr sz="1500">
+                <a:solidFill>
+                  <a:srgbClr val="C8DEED"/>
+                </a:solidFill>
+              </a:rPr>
+              <a:t>      ~15-20 jours-homme pour le projet école</a:t>
+            </a:r>
+          </a:p>
+          <a:p>
+            <a:pPr>
+              <a:spcAft>
+                <a:spcPts val="1000"/>
+              </a:spcAft>
+            </a:pPr>
+            <a:r>
+              <a:rPr sz="2000" b="1">
+                <a:solidFill>
+                  <a:srgbClr val="FFFFFF"/>
+                </a:solidFill>
+              </a:rPr>
+              <a:t>▸  Déploiement métier : ~10-15 k€ / borne</a:t>
+            </a:r>
+          </a:p>
+          <a:p>
+            <a:pPr>
+              <a:spcAft>
+                <a:spcPts val="1000"/>
+              </a:spcAft>
+            </a:pPr>
+            <a:r>
+              <a:rPr sz="1500">
+                <a:solidFill>
+                  <a:srgbClr val="C8DEED"/>
+                </a:solidFill>
+              </a:rPr>
+              <a:t>      Voirie standard (génie civil + raccordement) ; borne rapide DC : 30-50 k€ ; maintenance 500-1500 €/an</a:t>
+            </a:r>
+          </a:p>
+          <a:p>
+            <a:pPr>
+              <a:spcAft>
+                <a:spcPts val="1000"/>
+              </a:spcAft>
+            </a:pPr>
+            <a:r>
+              <a:rPr sz="2000" b="1">
+                <a:solidFill>
+                  <a:srgbClr val="FFFFFF"/>
+                </a:solidFill>
+              </a:rPr>
+              <a:t>▸  Rollout ordre de grandeur : ~90 M€ à 3 ans</a:t>
+            </a:r>
+          </a:p>
+          <a:p>
+            <a:pPr>
+              <a:spcAft>
+                <a:spcPts val="1000"/>
+              </a:spcAft>
+            </a:pPr>
+            <a:r>
+              <a:rPr sz="1500">
+                <a:solidFill>
+                  <a:srgbClr val="C8DEED"/>
+                </a:solidFill>
+              </a:rPr>
+              <a:t>      Scénario central ≈ 7 600 bornes × ~12 k€ — l'outil sert à PRIORISER cet investissement</a:t>
+            </a:r>
+          </a:p>
+        </p:txBody>
+      </p:sp>
+      <p:sp>
+        <p:nvSpPr>
+          <p:cNvPr id="7" name="TextBox 6"/>
+          <p:cNvSpPr txBox="1"/>
+          <p:nvPr/>
+        </p:nvSpPr>
+        <p:spPr>
+          <a:xfrm>
+            <a:off x="731520" y="6400800"/>
+            <a:ext cx="10607040" cy="365760"/>
+          </a:xfrm>
+          <a:prstGeom prst="rect">
+            <a:avLst/>
+          </a:prstGeom>
+          <a:noFill/>
+        </p:spPr>
+        <p:txBody>
+          <a:bodyPr wrap="square">
+            <a:spAutoFit/>
+          </a:bodyPr>
+          <a:lstStyle/>
+          <a:p>
+            <a:r>
+              <a:rPr sz="1000">
+                <a:solidFill>
+                  <a:srgbClr val="C8DEED"/>
+                </a:solidFill>
+              </a:rPr>
+              <a:t>Bornes de recharge VE — Paris · Projet Final Jedha   ·   Budget</a:t>
             </a:r>
           </a:p>
         </p:txBody>

</xml_diff>